<commit_message>
feat: update post image to use default from data, enhance styles
- Updated default post image in store.js
- Adjusted color variables in global.css for improved contrast
- Modified text colors in intro.css and navbar.css for better readability
- Enhanced layout and spacing in phase1.css and phase2.css for a more user-friendly interface
- Added new ethics and video script documentation to clarify app's purpose and functionality
- Revised content in build_deck.py to reflect accurate statistics and improve narrative flow
</commit_message>
<xml_diff>
--- a/docs/The-Misinformation-Lab-IEEE-2026.pptx
+++ b/docs/The-Misinformation-Lab-IEEE-2026.pptx
@@ -506,7 +506,13 @@
           <a:lstStyle/>
           <a:p>
             <a:r>
-              <a:t>Open here. The point of this slide is that the problem is not ignorance, it is speed and reflex. Every media-literacy tool teaches recognition; recognition is already there and it still fails. That is what justifies role reversal instead of another explainer. Verify both cited figures against your sources before submitting.</a:t>
+              <a:t>Open here. The point of this slide is that the problem is not ignorance, it is speed and reflex. Every media-literacy tool teaches recognition; recognition is already there and it still fails. That is what justifies role reversal instead of another explainer.</a:t>
+            </a:r>
+          </a:p>
+          <a:p/>
+          <a:p>
+            <a:r>
+              <a:t>Both figures are checked. The 2% is the Commission on Fake News (National Literacy Trust, June 2018). On the WEF: misinformation was the #1 two-year risk in the 2024 and 2025 Global Risks Reports and #2 in 2026, behind geoeconomic confrontation — so say 'three years running as one of the most severe', not 'number one', which is now out of date.</a:t>
             </a:r>
           </a:p>
         </p:txBody>
@@ -796,6 +802,12 @@
         <p:txBody>
           <a:bodyPr/>
           <a:lstStyle/>
+          <a:p>
+            <a:r>
+              <a:t>Full position is in docs/ETHICS.md — quote from it if pressed.</a:t>
+            </a:r>
+          </a:p>
+          <a:p/>
           <a:p>
             <a:r>
               <a:t>On ethics, be precise, because a judge may press on it. The app does let a student attach their own photo to a false headline — that is deliberate, because pairing a real image with a false claim is the most common real tactic there is, and doing it yourself teaches it faster than being told. What constrains it: the scenario is wholly fictional, the AI refuses every real name, and nothing ever leaves the student's own browser.</a:t>
@@ -3995,7 +4007,7 @@
                 </a:solidFill>
                 <a:latin typeface="Arial"/>
               </a:rPr>
-              <a:t>Media literacy is taught as knowledge — spot the red flags, check the source. But recognition was never the failure point. Speed is. A student who can define misinformation in a classroom still reshares it in four seconds on a phone.</a:t>
+              <a:t>Media literacy is taught as knowledge — spot the red flags, check the source. But recognition was never the failure point. Speed is. A student who can define misinformation in a classroom will still reshare it on a phone without stopping to think.</a:t>
             </a:r>
           </a:p>
         </p:txBody>
@@ -4081,7 +4093,7 @@
                 </a:solidFill>
                 <a:latin typeface="Georgia"/>
               </a:rPr>
-              <a:t>11%</a:t>
+              <a:t>2%</a:t>
             </a:r>
           </a:p>
         </p:txBody>
@@ -4126,7 +4138,7 @@
                 </a:solidFill>
                 <a:latin typeface="Arial"/>
               </a:rPr>
-              <a:t>of 11–17s can reliably tell a real news story from a fake one</a:t>
+              <a:t>of children have the critical literacy skills to tell a real news story from a fake one</a:t>
             </a:r>
           </a:p>
         </p:txBody>
@@ -4212,7 +4224,7 @@
                 </a:solidFill>
                 <a:latin typeface="Georgia"/>
               </a:rPr>
-              <a:t>#1</a:t>
+              <a:t>3 yrs</a:t>
             </a:r>
           </a:p>
         </p:txBody>
@@ -4257,7 +4269,7 @@
                 </a:solidFill>
                 <a:latin typeface="Arial"/>
               </a:rPr>
-              <a:t>short-term global risk, ahead of extreme weather and conflict</a:t>
+              <a:t>running as one of the most severe global risks, per the World Economic Forum</a:t>
             </a:r>
           </a:p>
         </p:txBody>
@@ -4293,13 +4305,13 @@
               </a:spcAft>
             </a:pPr>
             <a:r>
-              <a:rPr sz="800" b="0" i="0">
+              <a:rPr sz="750" b="0" i="0">
                 <a:solidFill>
                   <a:srgbClr val="5A5A64"/>
                 </a:solidFill>
                 <a:latin typeface="Arial"/>
               </a:rPr>
-              <a:t>Ofcom / National Literacy Trust  ·  WEF Global Risks Report</a:t>
+              <a:t>National Literacy Trust, Commission on Fake News (2018)  ·  WEF Global Risks Report 2024–2026</a:t>
             </a:r>
           </a:p>
         </p:txBody>
@@ -7721,7 +7733,7 @@
                 </a:solidFill>
                 <a:latin typeface="Arial"/>
               </a:rPr>
-              <a:t>Keyboard-complete.</a:t>
+              <a:t>Zero WCAG AA violations.</a:t>
             </a:r>
           </a:p>
         </p:txBody>
@@ -7766,7 +7778,7 @@
                 </a:solidFill>
                 <a:latin typeface="Arial"/>
               </a:rPr>
-              <a:t>Every screen, including the final reveal. Live-region announcements for screen readers, and reduced-motion honoured throughout.</a:t>
+              <a:t>Audited with axe-core across all fourteen screens. Keyboard-complete including the final reveal, live-region announcements, reduced-motion honoured.</a:t>
             </a:r>
           </a:p>
         </p:txBody>
@@ -7987,7 +7999,7 @@
                 </a:solidFill>
                 <a:latin typeface="Arial"/>
               </a:rPr>
-              <a:t>The AI refuses.</a:t>
+              <a:t>The AI declares itself.</a:t>
             </a:r>
           </a:p>
         </p:txBody>
@@ -8032,7 +8044,7 @@
                 </a:solidFill>
                 <a:latin typeface="Arial"/>
               </a:rPr>
-              <a:t>Name a real person, organisation or event and the strategist declines in character, stating why. It only ever works inside the scenario.</a:t>
+              <a:t>It refuses every real person, organisation and event — and carries a standing notice that it can be wrong and argues for whatever you ask it to.</a:t>
             </a:r>
           </a:p>
         </p:txBody>

</xml_diff>